<commit_message>
figures: export 600-dpi PNGs alongside vector PDFs; rebuild week9 deck with sharp figures
</commit_message>
<xml_diff>
--- a/judge_responses/Week 9 Presentation - Charlie Levy (v2).pptx
+++ b/judge_responses/Week 9 Presentation - Charlie Levy (v2).pptx
@@ -7002,7 +7002,7 @@
         <p:spPr>
           <a:xfrm>
             <a:off x="6400800" y="1325880"/>
-            <a:ext cx="5120640" cy="4204045"/>
+            <a:ext cx="5120640" cy="4203510"/>
           </a:xfrm>
           <a:prstGeom prst="rect">
             <a:avLst/>
@@ -7281,7 +7281,7 @@
         <p:spPr>
           <a:xfrm>
             <a:off x="6217920" y="1554480"/>
-            <a:ext cx="5486400" cy="3187598"/>
+            <a:ext cx="5486400" cy="3193576"/>
           </a:xfrm>
           <a:prstGeom prst="rect">
             <a:avLst/>

</xml_diff>